<commit_message>
Slides: badged PPTX of sd-04-038
</commit_message>
<xml_diff>
--- a/system-design-101/vi/lessons/sd-04-038/slides/sd-04-038.pptx
+++ b/system-design-101/vi/lessons/sd-04-038/slides/sd-04-038.pptx
@@ -2063,7 +2063,7 @@
         </p:nvSpPr>
         <p:spPr>
           <a:xfrm>
-            <a:off x="10477500" y="914400"/>
+            <a:off x="10477500" y="1295400"/>
             <a:ext cx="6896100" cy="2381250"/>
           </a:xfrm>
           <a:prstGeom prst="roundRect">
@@ -2090,7 +2090,7 @@
         </p:nvSpPr>
         <p:spPr>
           <a:xfrm>
-            <a:off x="10858500" y="1143000"/>
+            <a:off x="10858500" y="1524000"/>
             <a:ext cx="1143000" cy="1562100"/>
           </a:xfrm>
           <a:prstGeom prst="rect">
@@ -2129,7 +2129,7 @@
         </p:nvSpPr>
         <p:spPr>
           <a:xfrm>
-            <a:off x="12192000" y="1295400"/>
+            <a:off x="12192000" y="1676400"/>
             <a:ext cx="4953000" cy="590550"/>
           </a:xfrm>
           <a:prstGeom prst="rect">
@@ -2179,7 +2179,7 @@
         </p:nvSpPr>
         <p:spPr>
           <a:xfrm>
-            <a:off x="12192000" y="1809750"/>
+            <a:off x="12192000" y="2190750"/>
             <a:ext cx="4857750" cy="1143000"/>
           </a:xfrm>
           <a:prstGeom prst="rect">
@@ -2298,7 +2298,7 @@
         </p:nvSpPr>
         <p:spPr>
           <a:xfrm>
-            <a:off x="10477500" y="3524250"/>
+            <a:off x="10477500" y="3905250"/>
             <a:ext cx="6896100" cy="2381250"/>
           </a:xfrm>
           <a:prstGeom prst="roundRect">
@@ -2325,7 +2325,7 @@
         </p:nvSpPr>
         <p:spPr>
           <a:xfrm>
-            <a:off x="10858500" y="3752850"/>
+            <a:off x="10858500" y="4133850"/>
             <a:ext cx="1143000" cy="1562100"/>
           </a:xfrm>
           <a:prstGeom prst="rect">
@@ -2364,7 +2364,7 @@
         </p:nvSpPr>
         <p:spPr>
           <a:xfrm>
-            <a:off x="12192000" y="3905250"/>
+            <a:off x="12192000" y="4286250"/>
             <a:ext cx="4953000" cy="590550"/>
           </a:xfrm>
           <a:prstGeom prst="rect">
@@ -2414,7 +2414,7 @@
         </p:nvSpPr>
         <p:spPr>
           <a:xfrm>
-            <a:off x="12192000" y="4419600"/>
+            <a:off x="12192000" y="4800600"/>
             <a:ext cx="4857750" cy="1143000"/>
           </a:xfrm>
           <a:prstGeom prst="rect">
@@ -2544,7 +2544,7 @@
         </p:nvSpPr>
         <p:spPr>
           <a:xfrm>
-            <a:off x="10477500" y="6134100"/>
+            <a:off x="10477500" y="6515100"/>
             <a:ext cx="6896100" cy="2381250"/>
           </a:xfrm>
           <a:prstGeom prst="roundRect">
@@ -2571,7 +2571,7 @@
         </p:nvSpPr>
         <p:spPr>
           <a:xfrm>
-            <a:off x="10858500" y="6362700"/>
+            <a:off x="10858500" y="6743700"/>
             <a:ext cx="1143000" cy="1562100"/>
           </a:xfrm>
           <a:prstGeom prst="rect">
@@ -2610,7 +2610,7 @@
         </p:nvSpPr>
         <p:spPr>
           <a:xfrm>
-            <a:off x="12192000" y="6515100"/>
+            <a:off x="12192000" y="6896100"/>
             <a:ext cx="4953000" cy="590550"/>
           </a:xfrm>
           <a:prstGeom prst="rect">
@@ -2671,7 +2671,7 @@
         </p:nvSpPr>
         <p:spPr>
           <a:xfrm>
-            <a:off x="12192000" y="7029450"/>
+            <a:off x="12192000" y="7410450"/>
             <a:ext cx="4857750" cy="1143000"/>
           </a:xfrm>
           <a:prstGeom prst="rect">
@@ -10263,7 +10263,7 @@
               <a:buNone/>
             </a:pPr>
             <a:r>
-              <a:rPr lang="en-US" sz="1950" dirty="0" spc="-6" kern="0">
+              <a:rPr lang="en-US" sz="1950" dirty="0" spc="-7" kern="0">
                 <a:solidFill>
                   <a:srgbClr val="9AA0B5"/>
                 </a:solidFill>
@@ -10271,10 +10271,10 @@
                 <a:ea typeface="Be Vietnam Pro" pitchFamily="34" charset="-122"/>
                 <a:cs typeface="Be Vietnam Pro" pitchFamily="34" charset="-120"/>
               </a:rPr>
-              <a:t>Đọc</a:t>
-            </a:r>
-            <a:r>
-              <a:rPr lang="en-US" sz="1950" dirty="0" spc="-7" kern="0">
+              <a:t>Thấy</a:t>
+            </a:r>
+            <a:r>
+              <a:rPr lang="en-US" sz="1950" dirty="0" spc="0" kern="0">
                 <a:solidFill>
                   <a:srgbClr val="9AA0B5"/>
                 </a:solidFill>
@@ -10282,10 +10282,10 @@
                 <a:ea typeface="Be Vietnam Pro" pitchFamily="34" charset="-122"/>
                 <a:cs typeface="Be Vietnam Pro" pitchFamily="34" charset="-120"/>
               </a:rPr>
-              <a:t> thấy</a:t>
-            </a:r>
-            <a:r>
-              <a:rPr lang="en-US" sz="1950" dirty="0" spc="-1" kern="0">
+              <a:t> lần</a:t>
+            </a:r>
+            <a:r>
+              <a:rPr lang="en-US" sz="1950" dirty="0" spc="1" kern="0">
                 <a:solidFill>
                   <a:srgbClr val="9AA0B5"/>
                 </a:solidFill>
@@ -10293,10 +10293,10 @@
                 <a:ea typeface="Be Vietnam Pro" pitchFamily="34" charset="-122"/>
                 <a:cs typeface="Be Vietnam Pro" pitchFamily="34" charset="-120"/>
               </a:rPr>
-              <a:t> lần</a:t>
-            </a:r>
-            <a:r>
-              <a:rPr lang="en-US" sz="1950" dirty="0" spc="1" kern="0">
+              <a:t> ghi</a:t>
+            </a:r>
+            <a:r>
+              <a:rPr lang="en-US" sz="1950" dirty="0" spc="0" kern="0">
                 <a:solidFill>
                   <a:srgbClr val="9AA0B5"/>
                 </a:solidFill>
@@ -10304,10 +10304,10 @@
                 <a:ea typeface="Be Vietnam Pro" pitchFamily="34" charset="-122"/>
                 <a:cs typeface="Be Vietnam Pro" pitchFamily="34" charset="-120"/>
               </a:rPr>
-              <a:t> ghi</a:t>
-            </a:r>
-            <a:r>
-              <a:rPr lang="en-US" sz="1950" dirty="0" spc="0" kern="0">
+              <a:t> mới</a:t>
+            </a:r>
+            <a:r>
+              <a:rPr lang="en-US" sz="1950" dirty="0" spc="-8" kern="0">
                 <a:solidFill>
                   <a:srgbClr val="9AA0B5"/>
                 </a:solidFill>
@@ -10315,10 +10315,10 @@
                 <a:ea typeface="Be Vietnam Pro" pitchFamily="34" charset="-122"/>
                 <a:cs typeface="Be Vietnam Pro" pitchFamily="34" charset="-120"/>
               </a:rPr>
-              <a:t> mới</a:t>
-            </a:r>
-            <a:r>
-              <a:rPr lang="en-US" sz="1950" dirty="0" spc="-8" kern="0">
+              <a:t> nhất</a:t>
+            </a:r>
+            <a:r>
+              <a:rPr lang="en-US" sz="1950" dirty="0" spc="-2" kern="0">
                 <a:solidFill>
                   <a:srgbClr val="9AA0B5"/>
                 </a:solidFill>
@@ -10326,10 +10326,10 @@
                 <a:ea typeface="Be Vietnam Pro" pitchFamily="34" charset="-122"/>
                 <a:cs typeface="Be Vietnam Pro" pitchFamily="34" charset="-120"/>
               </a:rPr>
-              <a:t> nhất</a:t>
-            </a:r>
-            <a:r>
-              <a:rPr lang="en-US" sz="1950" dirty="0" spc="-2" kern="0">
+              <a:t> ·</a:t>
+            </a:r>
+            <a:r>
+              <a:rPr lang="en-US" sz="1950" dirty="0" spc="2" kern="0">
                 <a:solidFill>
                   <a:srgbClr val="9AA0B5"/>
                 </a:solidFill>
@@ -10337,10 +10337,10 @@
                 <a:ea typeface="Be Vietnam Pro" pitchFamily="34" charset="-122"/>
                 <a:cs typeface="Be Vietnam Pro" pitchFamily="34" charset="-120"/>
               </a:rPr>
-              <a:t> ·</a:t>
-            </a:r>
-            <a:r>
-              <a:rPr lang="en-US" sz="1950" dirty="0" spc="2" kern="0">
+              <a:t> giữ đúng</a:t>
+            </a:r>
+            <a:r>
+              <a:rPr lang="en-US" sz="1950" dirty="0" spc="-14" kern="0">
                 <a:solidFill>
                   <a:srgbClr val="9AA0B5"/>
                 </a:solidFill>
@@ -10348,32 +10348,10 @@
                 <a:ea typeface="Be Vietnam Pro" pitchFamily="34" charset="-122"/>
                 <a:cs typeface="Be Vietnam Pro" pitchFamily="34" charset="-120"/>
               </a:rPr>
-              <a:t> giữ</a:t>
-            </a:r>
-            <a:r>
-              <a:rPr lang="en-US" sz="1950" dirty="0" spc="3" kern="0">
-                <a:solidFill>
-                  <a:srgbClr val="9AA0B5"/>
-                </a:solidFill>
-                <a:latin typeface="Be Vietnam Pro" pitchFamily="34" charset="0"/>
-                <a:ea typeface="Be Vietnam Pro" pitchFamily="34" charset="-122"/>
-                <a:cs typeface="Be Vietnam Pro" pitchFamily="34" charset="-120"/>
-              </a:rPr>
-              <a:t> đúng</a:t>
-            </a:r>
-            <a:r>
-              <a:rPr lang="en-US" sz="1950" dirty="0" spc="-15" kern="0">
-                <a:solidFill>
-                  <a:srgbClr val="9AA0B5"/>
-                </a:solidFill>
-                <a:latin typeface="Be Vietnam Pro" pitchFamily="34" charset="0"/>
-                <a:ea typeface="Be Vietnam Pro" pitchFamily="34" charset="-122"/>
-                <a:cs typeface="Be Vietnam Pro" pitchFamily="34" charset="-120"/>
-              </a:rPr>
               <a:t> ràng</a:t>
             </a:r>
             <a:r>
-              <a:rPr lang="en-US" sz="1950" dirty="0" spc="-3" kern="0">
+              <a:rPr lang="en-US" sz="1950" dirty="0" spc="-4" kern="0">
                 <a:solidFill>
                   <a:srgbClr val="9AA0B5"/>
                 </a:solidFill>
@@ -14156,17 +14134,6 @@
                 <a:cs typeface="Be Vietnam Pro" pitchFamily="34" charset="-120"/>
               </a:rPr>
               <a:t> ·</a:t>
-            </a:r>
-            <a:r>
-              <a:rPr lang="en-US" sz="2100" dirty="0" spc="0" kern="0">
-                <a:solidFill>
-                  <a:srgbClr val="6B6A66"/>
-                </a:solidFill>
-                <a:latin typeface="Be Vietnam Pro" pitchFamily="34" charset="0"/>
-                <a:ea typeface="Be Vietnam Pro" pitchFamily="34" charset="-122"/>
-                <a:cs typeface="Be Vietnam Pro" pitchFamily="34" charset="-120"/>
-              </a:rPr>
-              <a:t> chỉ</a:t>
             </a:r>
             <a:r>
               <a:rPr lang="en-US" sz="2100" dirty="0" spc="-17" kern="0">

</xml_diff>